<commit_message>
Slides: sd-05-004 check question keeps both premises (users and speed)
Co-Authored-By: Claude Opus 5.5 <noreply@anthropic.com>
Claude-Session: https://claude.ai/code/session_01C9pH8NnezrynRr5dznPeP3
</commit_message>
<xml_diff>
--- a/system-design-101/vi/lessons/sd-05-004/slides/sd-05-004.pptx
+++ b/system-design-101/vi/lessons/sd-05-004/slides/sd-05-004.pptx
@@ -13143,7 +13143,7 @@
               <a:t>Chưa</a:t>
             </a:r>
             <a:r>
-              <a:rPr lang="en-US" sz="6900" dirty="0" spc="2" kern="0">
+              <a:rPr lang="en-US" sz="6900" dirty="0" spc="-28" kern="0">
                 <a:solidFill>
                   <a:srgbClr val="F3EEE3"/>
                 </a:solidFill>
@@ -13151,10 +13151,10 @@
                 <a:ea typeface="Bricolage Grotesque ExtraBold" pitchFamily="34" charset="-122"/>
                 <a:cs typeface="Bricolage Grotesque ExtraBold" pitchFamily="34" charset="-120"/>
               </a:rPr>
-              <a:t> biết</a:t>
-            </a:r>
-            <a:r>
-              <a:rPr lang="en-US" sz="6900" dirty="0" spc="0" kern="0">
+              <a:t> rõ</a:t>
+            </a:r>
+            <a:r>
+              <a:rPr lang="en-US" sz="6900" dirty="0" spc="2" kern="0">
                 <a:solidFill>
                   <a:srgbClr val="F3EEE3"/>
                 </a:solidFill>
@@ -13162,10 +13162,10 @@
                 <a:ea typeface="Bricolage Grotesque ExtraBold" pitchFamily="34" charset="-122"/>
                 <a:cs typeface="Bricolage Grotesque ExtraBold" pitchFamily="34" charset="-120"/>
               </a:rPr>
-              <a:t> quy</a:t>
-            </a:r>
-            <a:r>
-              <a:rPr lang="en-US" sz="6900" dirty="0" spc="-5" kern="0">
+              <a:t> số</a:t>
+            </a:r>
+            <a:r>
+              <a:rPr lang="en-US" sz="6900" dirty="0" spc="-59" kern="0">
                 <a:solidFill>
                   <a:srgbClr val="F3EEE3"/>
                 </a:solidFill>
@@ -13173,10 +13173,10 @@
                 <a:ea typeface="Bricolage Grotesque ExtraBold" pitchFamily="34" charset="-122"/>
                 <a:cs typeface="Bricolage Grotesque ExtraBold" pitchFamily="34" charset="-120"/>
               </a:rPr>
-              <a:t> mô:</a:t>
-            </a:r>
-            <a:r>
-              <a:rPr lang="en-US" sz="6900" dirty="0" spc="1" kern="0">
+              <a:t> người,</a:t>
+            </a:r>
+            <a:r>
+              <a:rPr lang="en-US" sz="6900" dirty="0" spc="-29" kern="0">
                 <a:solidFill>
                   <a:srgbClr val="F3EEE3"/>
                 </a:solidFill>
@@ -13184,10 +13184,10 @@
                 <a:ea typeface="Bricolage Grotesque ExtraBold" pitchFamily="34" charset="-122"/>
                 <a:cs typeface="Bricolage Grotesque ExtraBold" pitchFamily="34" charset="-120"/>
               </a:rPr>
-              <a:t> bỏ</a:t>
-            </a:r>
-            <a:r>
-              <a:rPr lang="en-US" sz="6900" dirty="0" spc="-9" kern="0">
+              <a:t> tốc</a:t>
+            </a:r>
+            <a:r>
+              <a:rPr lang="en-US" sz="6900" dirty="0" spc="9" kern="0">
                 <a:solidFill>
                   <a:srgbClr val="F3EEE3"/>
                 </a:solidFill>
@@ -13195,10 +13195,10 @@
                 <a:ea typeface="Bricolage Grotesque ExtraBold" pitchFamily="34" charset="-122"/>
                 <a:cs typeface="Bricolage Grotesque ExtraBold" pitchFamily="34" charset="-120"/>
               </a:rPr>
-              <a:t> sót</a:t>
-            </a:r>
-            <a:r>
-              <a:rPr lang="en-US" sz="6900" dirty="0" spc="-95" kern="0">
+              <a:t> độ:</a:t>
+            </a:r>
+            <a:r>
+              <a:rPr lang="en-US" sz="6900" dirty="0" spc="7" kern="0">
                 <a:solidFill>
                   <a:srgbClr val="F3EEE3"/>
                 </a:solidFill>
@@ -13206,10 +13206,21 @@
                 <a:ea typeface="Bricolage Grotesque ExtraBold" pitchFamily="34" charset="-122"/>
                 <a:cs typeface="Bricolage Grotesque ExtraBold" pitchFamily="34" charset="-120"/>
               </a:rPr>
+              <a:t> thiếu</a:t>
+            </a:r>
+            <a:r>
+              <a:rPr lang="en-US" sz="6900" dirty="0" spc="-95" kern="0">
+                <a:solidFill>
+                  <a:srgbClr val="F3EEE3"/>
+                </a:solidFill>
+                <a:latin typeface="Bricolage Grotesque ExtraBold" pitchFamily="34" charset="0"/>
+                <a:ea typeface="Bricolage Grotesque ExtraBold" pitchFamily="34" charset="-122"/>
+                <a:cs typeface="Bricolage Grotesque ExtraBold" pitchFamily="34" charset="-120"/>
+              </a:rPr>
               <a:t> bước</a:t>
             </a:r>
             <a:r>
-              <a:rPr lang="en-US" sz="6900" dirty="0" spc="-39" kern="0">
+              <a:rPr lang="en-US" sz="6900" dirty="0" spc="-40" kern="0">
                 <a:solidFill>
                   <a:srgbClr val="F3EEE3"/>
                 </a:solidFill>

</xml_diff>